<commit_message>
docs: actualizar reglas de estilo PPTX (Calibri, tamaños reducidos)
- Tipografía universal Arial → Calibri (pptx_rules.json + journal)
- Títulos 40→30pt, subtítulos 32→26pt, contenido 24→20pt
- Regenerar Presentacion_DAPT_UC_Final.pptx con las nuevas reglas

Co-Authored-By: Claude Opus 4.8 <noreply@anthropic.com>
</commit_message>
<xml_diff>
--- a/projects/2026-06-12_dapt_acv/Presentacion_DAPT_UC_Final.pptx
+++ b/projects/2026-06-12_dapt_acv/Presentacion_DAPT_UC_Final.pptx
@@ -3448,8 +3448,8 @@
           <a:lstStyle/>
           <a:p>
             <a:pPr>
-              <a:defRPr sz="4000">
-                <a:latin typeface="Arial"/>
+              <a:defRPr sz="3000">
+                <a:latin typeface="Calibri"/>
               </a:defRPr>
             </a:pPr>
             <a:r>
@@ -3474,8 +3474,8 @@
           <a:lstStyle/>
           <a:p>
             <a:pPr>
-              <a:defRPr sz="2400">
-                <a:latin typeface="Arial"/>
+              <a:defRPr sz="2000">
+                <a:latin typeface="Calibri"/>
               </a:defRPr>
             </a:pPr>
             <a:r>
@@ -3484,8 +3484,8 @@
           </a:p>
           <a:p>
             <a:pPr>
-              <a:defRPr sz="2400">
-                <a:latin typeface="Arial"/>
+              <a:defRPr sz="2000">
+                <a:latin typeface="Calibri"/>
               </a:defRPr>
             </a:pPr>
             <a:r>
@@ -3494,8 +3494,8 @@
           </a:p>
           <a:p>
             <a:pPr>
-              <a:defRPr sz="2400">
-                <a:latin typeface="Arial"/>
+              <a:defRPr sz="2000">
+                <a:latin typeface="Calibri"/>
               </a:defRPr>
             </a:pPr>
             <a:r>
@@ -3504,8 +3504,8 @@
           </a:p>
           <a:p>
             <a:pPr>
-              <a:defRPr sz="2400">
-                <a:latin typeface="Arial"/>
+              <a:defRPr sz="2000">
+                <a:latin typeface="Calibri"/>
               </a:defRPr>
             </a:pPr>
             <a:r>
@@ -3538,7 +3538,7 @@
           <a:p>
             <a:pPr algn="l">
               <a:defRPr sz="1000">
-                <a:latin typeface="Arial"/>
+                <a:latin typeface="Calibri"/>
               </a:defRPr>
             </a:pPr>
             <a:r>
@@ -3581,8 +3581,8 @@
           <a:lstStyle/>
           <a:p>
             <a:pPr>
-              <a:defRPr sz="4000">
-                <a:latin typeface="Arial"/>
+              <a:defRPr sz="3000">
+                <a:latin typeface="Calibri"/>
               </a:defRPr>
             </a:pPr>
             <a:r>
@@ -3607,8 +3607,8 @@
           <a:lstStyle/>
           <a:p>
             <a:pPr>
-              <a:defRPr sz="2400">
-                <a:latin typeface="Arial"/>
+              <a:defRPr sz="2000">
+                <a:latin typeface="Calibri"/>
               </a:defRPr>
             </a:pPr>
             <a:r>
@@ -3617,8 +3617,8 @@
           </a:p>
           <a:p>
             <a:pPr>
-              <a:defRPr sz="2400">
-                <a:latin typeface="Arial"/>
+              <a:defRPr sz="2000">
+                <a:latin typeface="Calibri"/>
               </a:defRPr>
             </a:pPr>
             <a:r>
@@ -3627,8 +3627,8 @@
           </a:p>
           <a:p>
             <a:pPr>
-              <a:defRPr sz="2400">
-                <a:latin typeface="Arial"/>
+              <a:defRPr sz="2000">
+                <a:latin typeface="Calibri"/>
               </a:defRPr>
             </a:pPr>
             <a:r>
@@ -3661,7 +3661,7 @@
           <a:p>
             <a:pPr algn="l">
               <a:defRPr sz="1000">
-                <a:latin typeface="Arial"/>
+                <a:latin typeface="Calibri"/>
               </a:defRPr>
             </a:pPr>
             <a:r>
@@ -4018,8 +4018,8 @@
           <a:lstStyle/>
           <a:p>
             <a:pPr>
-              <a:defRPr sz="4000">
-                <a:latin typeface="Arial"/>
+              <a:defRPr sz="3000">
+                <a:latin typeface="Calibri"/>
               </a:defRPr>
             </a:pPr>
             <a:r>
@@ -4044,8 +4044,8 @@
           <a:lstStyle/>
           <a:p>
             <a:pPr>
-              <a:defRPr sz="3200">
-                <a:latin typeface="Arial"/>
+              <a:defRPr sz="2600">
+                <a:latin typeface="Calibri"/>
               </a:defRPr>
             </a:pPr>
             <a:r>
@@ -4054,8 +4054,8 @@
           </a:p>
           <a:p>
             <a:pPr>
-              <a:defRPr sz="3200">
-                <a:latin typeface="Arial"/>
+              <a:defRPr sz="2600">
+                <a:latin typeface="Calibri"/>
               </a:defRPr>
             </a:pPr>
             <a:r>
@@ -4098,8 +4098,8 @@
           <a:lstStyle/>
           <a:p>
             <a:pPr>
-              <a:defRPr sz="4000">
-                <a:latin typeface="Arial"/>
+              <a:defRPr sz="3000">
+                <a:latin typeface="Calibri"/>
               </a:defRPr>
             </a:pPr>
             <a:r>
@@ -4124,8 +4124,8 @@
           <a:lstStyle/>
           <a:p>
             <a:pPr>
-              <a:defRPr sz="2400">
-                <a:latin typeface="Arial"/>
+              <a:defRPr sz="2000">
+                <a:latin typeface="Calibri"/>
               </a:defRPr>
             </a:pPr>
             <a:r>
@@ -4134,8 +4134,8 @@
           </a:p>
           <a:p>
             <a:pPr>
-              <a:defRPr sz="2400">
-                <a:latin typeface="Arial"/>
+              <a:defRPr sz="2000">
+                <a:latin typeface="Calibri"/>
               </a:defRPr>
             </a:pPr>
             <a:r>
@@ -4144,8 +4144,8 @@
           </a:p>
           <a:p>
             <a:pPr>
-              <a:defRPr sz="2400">
-                <a:latin typeface="Arial"/>
+              <a:defRPr sz="2000">
+                <a:latin typeface="Calibri"/>
               </a:defRPr>
             </a:pPr>
             <a:r>
@@ -4154,8 +4154,8 @@
           </a:p>
           <a:p>
             <a:pPr>
-              <a:defRPr sz="2400">
-                <a:latin typeface="Arial"/>
+              <a:defRPr sz="2000">
+                <a:latin typeface="Calibri"/>
               </a:defRPr>
             </a:pPr>
             <a:r>
@@ -4212,7 +4212,7 @@
           <a:p>
             <a:pPr algn="l">
               <a:defRPr sz="1000">
-                <a:latin typeface="Arial"/>
+                <a:latin typeface="Calibri"/>
               </a:defRPr>
             </a:pPr>
             <a:r>
@@ -4255,8 +4255,8 @@
           <a:lstStyle/>
           <a:p>
             <a:pPr>
-              <a:defRPr sz="4000">
-                <a:latin typeface="Arial"/>
+              <a:defRPr sz="3000">
+                <a:latin typeface="Calibri"/>
               </a:defRPr>
             </a:pPr>
             <a:r>
@@ -4281,8 +4281,8 @@
           <a:lstStyle/>
           <a:p>
             <a:pPr>
-              <a:defRPr sz="2400">
-                <a:latin typeface="Arial"/>
+              <a:defRPr sz="2000">
+                <a:latin typeface="Calibri"/>
               </a:defRPr>
             </a:pPr>
             <a:r>
@@ -4291,8 +4291,8 @@
           </a:p>
           <a:p>
             <a:pPr>
-              <a:defRPr sz="2400">
-                <a:latin typeface="Arial"/>
+              <a:defRPr sz="2000">
+                <a:latin typeface="Calibri"/>
               </a:defRPr>
             </a:pPr>
             <a:r>
@@ -4301,8 +4301,8 @@
           </a:p>
           <a:p>
             <a:pPr>
-              <a:defRPr sz="2400">
-                <a:latin typeface="Arial"/>
+              <a:defRPr sz="2000">
+                <a:latin typeface="Calibri"/>
               </a:defRPr>
             </a:pPr>
             <a:r>
@@ -4311,8 +4311,8 @@
           </a:p>
           <a:p>
             <a:pPr>
-              <a:defRPr sz="2400">
-                <a:latin typeface="Arial"/>
+              <a:defRPr sz="2000">
+                <a:latin typeface="Calibri"/>
               </a:defRPr>
             </a:pPr>
             <a:r>
@@ -4369,7 +4369,7 @@
           <a:p>
             <a:pPr algn="l">
               <a:defRPr sz="1000">
-                <a:latin typeface="Arial"/>
+                <a:latin typeface="Calibri"/>
               </a:defRPr>
             </a:pPr>
             <a:r>

</xml_diff>